<commit_message>
Add ImagineSignal offline MVP, live xAI transport, and the Grokathon kit
Offline MVP plus a live provider transport implemented against two authorized
smoke probes on 2026-08-05. Evidence remains UNIT_TESTED, FROZEN_REPLAY, and
SIMULATED. No X Ads read, no publish, no spend beyond the two $0.02 probes
logged in hackathon/COST_LEDGER.md. Production is NO_GO and the action ceiling
is TEST.

468 passed, deterministic core at 100 percent line and branch, offline artifact
digest b17e9105 unchanged.
</commit_message>
<xml_diff>
--- a/slides/adjacency_deck.pptx
+++ b/slides/adjacency_deck.pptx
@@ -14,6 +14,10 @@
     <p:sldId id="262" r:id="rId14"/>
     <p:sldId id="263" r:id="rId15"/>
     <p:sldId id="264" r:id="rId16"/>
+    <p:sldId id="265" r:id="rId17"/>
+    <p:sldId id="266" r:id="rId18"/>
+    <p:sldId id="267" r:id="rId19"/>
+    <p:sldId id="268" r:id="rId20"/>
   </p:sldIdLst>
   <p:sldSz cx="12191695" cy="6858000" type="screen4x3"/>
   <p:notesSz cx="6858000" cy="9144000"/>
@@ -535,6 +539,286 @@
 </p:notes>
 </file>
 
+<file path=ppt/notesSlides/notesSlide10.xml><?xml version="1.0" encoding="utf-8"?>
+<p:notes xmlns:a="http://schemas.openxmlformats.org/drawingml/2006/main" xmlns:p="http://schemas.openxmlformats.org/presentationml/2006/main" xmlns:r="http://schemas.openxmlformats.org/officeDocument/2006/relationships">
+  <p:cSld>
+    <p:spTree>
+      <p:nvGrpSpPr>
+        <p:cNvPr id="1" name=""/>
+        <p:cNvGrpSpPr/>
+        <p:nvPr/>
+      </p:nvGrpSpPr>
+      <p:grpSpPr>
+        <a:xfrm>
+          <a:off x="0" y="0"/>
+          <a:ext cx="0" cy="0"/>
+          <a:chOff x="0" y="0"/>
+          <a:chExt cx="0" cy="0"/>
+        </a:xfrm>
+      </p:grpSpPr>
+      <p:sp>
+        <p:nvSpPr>
+          <p:cNvPr id="2" name="Slide Image Placeholder 1"/>
+          <p:cNvSpPr>
+            <a:spLocks noGrp="1"/>
+          </p:cNvSpPr>
+          <p:nvPr>
+            <p:ph type="sldImg" idx="2"/>
+          </p:nvPr>
+        </p:nvSpPr>
+        <p:spPr/>
+      </p:sp>
+      <p:sp>
+        <p:nvSpPr>
+          <p:cNvPr id="3" name="Notes Placeholder 2"/>
+          <p:cNvSpPr>
+            <a:spLocks noGrp="1"/>
+          </p:cNvSpPr>
+          <p:nvPr>
+            <p:ph type="body" idx="3" sz="quarter"/>
+          </p:nvPr>
+        </p:nvSpPr>
+        <p:spPr/>
+        <p:txBody>
+          <a:bodyPr/>
+          <a:lstStyle/>
+          <a:p>
+            <a:r>
+              <a:t>This is the difference between a demo and a system. A demo calls the API from inside the business logic. Here the business logic is tested without a network, a key, or a bill. The cost interlock is the detail worth slowing down on: an unreported cost is a distinct state that blocks further calls, which is what makes it safe to leave running unattended.</a:t>
+            </a:r>
+          </a:p>
+        </p:txBody>
+      </p:sp>
+      <p:sp>
+        <p:nvSpPr>
+          <p:cNvPr id="4" name="Slide Number Placeholder 3"/>
+          <p:cNvSpPr>
+            <a:spLocks noGrp="1"/>
+          </p:cNvSpPr>
+          <p:nvPr>
+            <p:ph type="sldNum" idx="5" sz="quarter"/>
+          </p:nvPr>
+        </p:nvSpPr>
+        <p:spPr/>
+      </p:sp>
+    </p:spTree>
+  </p:cSld>
+  <p:clrMapOvr>
+    <a:masterClrMapping/>
+  </p:clrMapOvr>
+</p:notes>
+</file>
+
+<file path=ppt/notesSlides/notesSlide11.xml><?xml version="1.0" encoding="utf-8"?>
+<p:notes xmlns:a="http://schemas.openxmlformats.org/drawingml/2006/main" xmlns:p="http://schemas.openxmlformats.org/presentationml/2006/main" xmlns:r="http://schemas.openxmlformats.org/officeDocument/2006/relationships">
+  <p:cSld>
+    <p:spTree>
+      <p:nvGrpSpPr>
+        <p:cNvPr id="1" name=""/>
+        <p:cNvGrpSpPr/>
+        <p:nvPr/>
+      </p:nvGrpSpPr>
+      <p:grpSpPr>
+        <a:xfrm>
+          <a:off x="0" y="0"/>
+          <a:ext cx="0" cy="0"/>
+          <a:chOff x="0" y="0"/>
+          <a:chExt cx="0" cy="0"/>
+        </a:xfrm>
+      </p:grpSpPr>
+      <p:sp>
+        <p:nvSpPr>
+          <p:cNvPr id="2" name="Slide Image Placeholder 1"/>
+          <p:cNvSpPr>
+            <a:spLocks noGrp="1"/>
+          </p:cNvSpPr>
+          <p:nvPr>
+            <p:ph type="sldImg" idx="2"/>
+          </p:nvPr>
+        </p:nvSpPr>
+        <p:spPr/>
+      </p:sp>
+      <p:sp>
+        <p:nvSpPr>
+          <p:cNvPr id="3" name="Notes Placeholder 2"/>
+          <p:cNvSpPr>
+            <a:spLocks noGrp="1"/>
+          </p:cNvSpPr>
+          <p:nvPr>
+            <p:ph type="body" idx="3" sz="quarter"/>
+          </p:nvPr>
+        </p:nvSpPr>
+        <p:spPr/>
+        <p:txBody>
+          <a:bodyPr/>
+          <a:lstStyle/>
+          <a:p>
+            <a:r>
+              <a:t>The refusal to overclaim is enforced in code rather than in a style guide. Early evidence admits only HOLD, REVIEW and STOP. One failed gate can only make the outcome stricter, never looser. This is the answer to why the system will not tell you a variant is better.</a:t>
+            </a:r>
+          </a:p>
+        </p:txBody>
+      </p:sp>
+      <p:sp>
+        <p:nvSpPr>
+          <p:cNvPr id="4" name="Slide Number Placeholder 3"/>
+          <p:cNvSpPr>
+            <a:spLocks noGrp="1"/>
+          </p:cNvSpPr>
+          <p:nvPr>
+            <p:ph type="sldNum" idx="5" sz="quarter"/>
+          </p:nvPr>
+        </p:nvSpPr>
+        <p:spPr/>
+      </p:sp>
+    </p:spTree>
+  </p:cSld>
+  <p:clrMapOvr>
+    <a:masterClrMapping/>
+  </p:clrMapOvr>
+</p:notes>
+</file>
+
+<file path=ppt/notesSlides/notesSlide12.xml><?xml version="1.0" encoding="utf-8"?>
+<p:notes xmlns:a="http://schemas.openxmlformats.org/drawingml/2006/main" xmlns:p="http://schemas.openxmlformats.org/presentationml/2006/main" xmlns:r="http://schemas.openxmlformats.org/officeDocument/2006/relationships">
+  <p:cSld>
+    <p:spTree>
+      <p:nvGrpSpPr>
+        <p:cNvPr id="1" name=""/>
+        <p:cNvGrpSpPr/>
+        <p:nvPr/>
+      </p:nvGrpSpPr>
+      <p:grpSpPr>
+        <a:xfrm>
+          <a:off x="0" y="0"/>
+          <a:ext cx="0" cy="0"/>
+          <a:chOff x="0" y="0"/>
+          <a:chExt cx="0" cy="0"/>
+        </a:xfrm>
+      </p:grpSpPr>
+      <p:sp>
+        <p:nvSpPr>
+          <p:cNvPr id="2" name="Slide Image Placeholder 1"/>
+          <p:cNvSpPr>
+            <a:spLocks noGrp="1"/>
+          </p:cNvSpPr>
+          <p:nvPr>
+            <p:ph type="sldImg" idx="2"/>
+          </p:nvPr>
+        </p:nvSpPr>
+        <p:spPr/>
+      </p:sp>
+      <p:sp>
+        <p:nvSpPr>
+          <p:cNvPr id="3" name="Notes Placeholder 2"/>
+          <p:cNvSpPr>
+            <a:spLocks noGrp="1"/>
+          </p:cNvSpPr>
+          <p:nvPr>
+            <p:ph type="body" idx="3" sz="quarter"/>
+          </p:nvPr>
+        </p:nvSpPr>
+        <p:spPr/>
+        <p:txBody>
+          <a:bodyPr/>
+          <a:lstStyle/>
+          <a:p>
+            <a:r>
+              <a:t>Fill the final highlight from the cost ledger after the event. If the ledger is empty at presentation time, say the accounting is built and the figure is not yet measured. Do not estimate it. The synthetic three-of-three versus two-of-three comparison in the artifact is a fixture-backed pipeline check, not measured provider efficiency.</a:t>
+            </a:r>
+          </a:p>
+        </p:txBody>
+      </p:sp>
+      <p:sp>
+        <p:nvSpPr>
+          <p:cNvPr id="4" name="Slide Number Placeholder 3"/>
+          <p:cNvSpPr>
+            <a:spLocks noGrp="1"/>
+          </p:cNvSpPr>
+          <p:nvPr>
+            <p:ph type="sldNum" idx="5" sz="quarter"/>
+          </p:nvPr>
+        </p:nvSpPr>
+        <p:spPr/>
+      </p:sp>
+    </p:spTree>
+  </p:cSld>
+  <p:clrMapOvr>
+    <a:masterClrMapping/>
+  </p:clrMapOvr>
+</p:notes>
+</file>
+
+<file path=ppt/notesSlides/notesSlide13.xml><?xml version="1.0" encoding="utf-8"?>
+<p:notes xmlns:a="http://schemas.openxmlformats.org/drawingml/2006/main" xmlns:p="http://schemas.openxmlformats.org/presentationml/2006/main" xmlns:r="http://schemas.openxmlformats.org/officeDocument/2006/relationships">
+  <p:cSld>
+    <p:spTree>
+      <p:nvGrpSpPr>
+        <p:cNvPr id="1" name=""/>
+        <p:cNvGrpSpPr/>
+        <p:nvPr/>
+      </p:nvGrpSpPr>
+      <p:grpSpPr>
+        <a:xfrm>
+          <a:off x="0" y="0"/>
+          <a:ext cx="0" cy="0"/>
+          <a:chOff x="0" y="0"/>
+          <a:chExt cx="0" cy="0"/>
+        </a:xfrm>
+      </p:grpSpPr>
+      <p:sp>
+        <p:nvSpPr>
+          <p:cNvPr id="2" name="Slide Image Placeholder 1"/>
+          <p:cNvSpPr>
+            <a:spLocks noGrp="1"/>
+          </p:cNvSpPr>
+          <p:nvPr>
+            <p:ph type="sldImg" idx="2"/>
+          </p:nvPr>
+        </p:nvSpPr>
+        <p:spPr/>
+      </p:sp>
+      <p:sp>
+        <p:nvSpPr>
+          <p:cNvPr id="3" name="Notes Placeholder 2"/>
+          <p:cNvSpPr>
+            <a:spLocks noGrp="1"/>
+          </p:cNvSpPr>
+          <p:nvPr>
+            <p:ph type="body" idx="3" sz="quarter"/>
+          </p:nvPr>
+        </p:nvSpPr>
+        <p:spPr/>
+        <p:txBody>
+          <a:bodyPr/>
+          <a:lstStyle/>
+          <a:p>
+            <a:r>
+              <a:t>Close on trust. The durable review round-trip is real, but the demo never depends on Temporal. The product path is also deliberately staged. Start with read-only evidence, run shadow evaluation, and activate policy clauses only after independent labels support it.</a:t>
+            </a:r>
+          </a:p>
+        </p:txBody>
+      </p:sp>
+      <p:sp>
+        <p:nvSpPr>
+          <p:cNvPr id="4" name="Slide Number Placeholder 3"/>
+          <p:cNvSpPr>
+            <a:spLocks noGrp="1"/>
+          </p:cNvSpPr>
+          <p:nvPr>
+            <p:ph type="sldNum" idx="5" sz="quarter"/>
+          </p:nvPr>
+        </p:nvSpPr>
+        <p:spPr/>
+      </p:sp>
+    </p:spTree>
+  </p:cSld>
+  <p:clrMapOvr>
+    <a:masterClrMapping/>
+  </p:clrMapOvr>
+</p:notes>
+</file>
+
 <file path=ppt/notesSlides/notesSlide2.xml><?xml version="1.0" encoding="utf-8"?>
 <p:notes xmlns:a="http://schemas.openxmlformats.org/drawingml/2006/main" xmlns:p="http://schemas.openxmlformats.org/presentationml/2006/main" xmlns:r="http://schemas.openxmlformats.org/officeDocument/2006/relationships">
   <p:cSld>
@@ -1070,7 +1354,7 @@
           <a:lstStyle/>
           <a:p>
             <a:r>
-              <a:t>Close on trust. The durable review round-trip is real, but the demo never depends on Temporal. The product path is also deliberately staged. Start with read-only evidence, run shadow evaluation, and activate policy clauses only after independent labels support it.</a:t>
+              <a:t>The discipline is the product, not the generation. If two things change you cannot attribute the difference, so the planner rejects a family that varies more than one declared attribute. The three assets here are synthetic fixtures, not measured creative quality.</a:t>
             </a:r>
           </a:p>
         </p:txBody>
@@ -4079,6 +4363,174 @@
       <p:pic>
         <p:nvPicPr>
           <p:cNvPr id="2" name="Picture 1" descr="slide_01.png"/>
+          <p:cNvPicPr>
+            <a:picLocks noChangeAspect="1"/>
+          </p:cNvPicPr>
+          <p:nvPr/>
+        </p:nvPicPr>
+        <p:blipFill>
+          <a:blip r:embed="rId2"/>
+          <a:stretch>
+            <a:fillRect/>
+          </a:stretch>
+        </p:blipFill>
+        <p:spPr>
+          <a:xfrm>
+            <a:off x="0" y="0"/>
+            <a:ext cx="12191695" cy="6858000"/>
+          </a:xfrm>
+          <a:prstGeom prst="rect">
+            <a:avLst/>
+          </a:prstGeom>
+        </p:spPr>
+      </p:pic>
+    </p:spTree>
+  </p:cSld>
+  <p:clrMapOvr>
+    <a:masterClrMapping/>
+  </p:clrMapOvr>
+</p:sld>
+</file>
+
+<file path=ppt/slides/slide10.xml><?xml version="1.0" encoding="utf-8"?>
+<p:sld xmlns:a="http://schemas.openxmlformats.org/drawingml/2006/main" xmlns:p="http://schemas.openxmlformats.org/presentationml/2006/main" xmlns:r="http://schemas.openxmlformats.org/officeDocument/2006/relationships">
+  <p:cSld>
+    <p:spTree>
+      <p:nvGrpSpPr>
+        <p:cNvPr id="1" name=""/>
+        <p:cNvGrpSpPr/>
+        <p:nvPr/>
+      </p:nvGrpSpPr>
+      <p:grpSpPr/>
+      <p:pic>
+        <p:nvPicPr>
+          <p:cNvPr id="2" name="Picture 1" descr="slide_10.png"/>
+          <p:cNvPicPr>
+            <a:picLocks noChangeAspect="1"/>
+          </p:cNvPicPr>
+          <p:nvPr/>
+        </p:nvPicPr>
+        <p:blipFill>
+          <a:blip r:embed="rId2"/>
+          <a:stretch>
+            <a:fillRect/>
+          </a:stretch>
+        </p:blipFill>
+        <p:spPr>
+          <a:xfrm>
+            <a:off x="0" y="0"/>
+            <a:ext cx="12191695" cy="6858000"/>
+          </a:xfrm>
+          <a:prstGeom prst="rect">
+            <a:avLst/>
+          </a:prstGeom>
+        </p:spPr>
+      </p:pic>
+    </p:spTree>
+  </p:cSld>
+  <p:clrMapOvr>
+    <a:masterClrMapping/>
+  </p:clrMapOvr>
+</p:sld>
+</file>
+
+<file path=ppt/slides/slide11.xml><?xml version="1.0" encoding="utf-8"?>
+<p:sld xmlns:a="http://schemas.openxmlformats.org/drawingml/2006/main" xmlns:p="http://schemas.openxmlformats.org/presentationml/2006/main" xmlns:r="http://schemas.openxmlformats.org/officeDocument/2006/relationships">
+  <p:cSld>
+    <p:spTree>
+      <p:nvGrpSpPr>
+        <p:cNvPr id="1" name=""/>
+        <p:cNvGrpSpPr/>
+        <p:nvPr/>
+      </p:nvGrpSpPr>
+      <p:grpSpPr/>
+      <p:pic>
+        <p:nvPicPr>
+          <p:cNvPr id="2" name="Picture 1" descr="slide_11.png"/>
+          <p:cNvPicPr>
+            <a:picLocks noChangeAspect="1"/>
+          </p:cNvPicPr>
+          <p:nvPr/>
+        </p:nvPicPr>
+        <p:blipFill>
+          <a:blip r:embed="rId2"/>
+          <a:stretch>
+            <a:fillRect/>
+          </a:stretch>
+        </p:blipFill>
+        <p:spPr>
+          <a:xfrm>
+            <a:off x="0" y="0"/>
+            <a:ext cx="12191695" cy="6858000"/>
+          </a:xfrm>
+          <a:prstGeom prst="rect">
+            <a:avLst/>
+          </a:prstGeom>
+        </p:spPr>
+      </p:pic>
+    </p:spTree>
+  </p:cSld>
+  <p:clrMapOvr>
+    <a:masterClrMapping/>
+  </p:clrMapOvr>
+</p:sld>
+</file>
+
+<file path=ppt/slides/slide12.xml><?xml version="1.0" encoding="utf-8"?>
+<p:sld xmlns:a="http://schemas.openxmlformats.org/drawingml/2006/main" xmlns:p="http://schemas.openxmlformats.org/presentationml/2006/main" xmlns:r="http://schemas.openxmlformats.org/officeDocument/2006/relationships">
+  <p:cSld>
+    <p:spTree>
+      <p:nvGrpSpPr>
+        <p:cNvPr id="1" name=""/>
+        <p:cNvGrpSpPr/>
+        <p:nvPr/>
+      </p:nvGrpSpPr>
+      <p:grpSpPr/>
+      <p:pic>
+        <p:nvPicPr>
+          <p:cNvPr id="2" name="Picture 1" descr="slide_12.png"/>
+          <p:cNvPicPr>
+            <a:picLocks noChangeAspect="1"/>
+          </p:cNvPicPr>
+          <p:nvPr/>
+        </p:nvPicPr>
+        <p:blipFill>
+          <a:blip r:embed="rId2"/>
+          <a:stretch>
+            <a:fillRect/>
+          </a:stretch>
+        </p:blipFill>
+        <p:spPr>
+          <a:xfrm>
+            <a:off x="0" y="0"/>
+            <a:ext cx="12191695" cy="6858000"/>
+          </a:xfrm>
+          <a:prstGeom prst="rect">
+            <a:avLst/>
+          </a:prstGeom>
+        </p:spPr>
+      </p:pic>
+    </p:spTree>
+  </p:cSld>
+  <p:clrMapOvr>
+    <a:masterClrMapping/>
+  </p:clrMapOvr>
+</p:sld>
+</file>
+
+<file path=ppt/slides/slide13.xml><?xml version="1.0" encoding="utf-8"?>
+<p:sld xmlns:a="http://schemas.openxmlformats.org/drawingml/2006/main" xmlns:p="http://schemas.openxmlformats.org/presentationml/2006/main" xmlns:r="http://schemas.openxmlformats.org/officeDocument/2006/relationships">
+  <p:cSld>
+    <p:spTree>
+      <p:nvGrpSpPr>
+        <p:cNvPr id="1" name=""/>
+        <p:cNvGrpSpPr/>
+        <p:nvPr/>
+      </p:nvGrpSpPr>
+      <p:grpSpPr/>
+      <p:pic>
+        <p:nvPicPr>
+          <p:cNvPr id="2" name="Picture 1" descr="slide_13.png"/>
           <p:cNvPicPr>
             <a:picLocks noChangeAspect="1"/>
           </p:cNvPicPr>

</xml_diff>